<commit_message>
test(fixtures): replace carbon/sustainability sample content with AI topics
- samples group B (EN): ai-models-intro, context-engineering-rag, ai-agents-mcp
  (was decarbonization-intro, low-carbon-materials, circular-economy); ES energy
  optimisation slide -> generative assistants; manifest + pptx regenerated
- multideck fixtures: climate-action -> ai-fundamentals,
  transition-energetique -> ia-generative-fr, innovacion-industrial ->
  agentes-ia-produccion; queries/specs/mocks/scripts/docs updated
- podcast/quicktest/sample generators rewritten around AI in production
- backend test strings de-carbonised; drop decarbonization keywords from avatar
  benefit-gesture list

Co-authored-by: Copilot App <223556219+Copilot@users.noreply.github.com>
Copilot-Session: 9d85d55c-b7a4-4682-a057-b94208dcb06e
</commit_message>
<xml_diff>
--- a/tests/fixtures/samples/ia-en-produccion.pptx
+++ b/tests/fixtures/samples/ia-en-produccion.pptx
@@ -646,7 +646,7 @@
           <a:lstStyle/>
           <a:p>
             <a:r>
-              <a:t>La optimización energética basada en IA ajusta consignas en tiempo real según demanda y condiciones. Ahorros típicos de cinco a quince por ciento reducen directamente las emisiones de alcance dos.</a:t>
+              <a:t>Los asistentes con IA generativa responden a los operarios a partir de manuales y procedimientos mediante RAG. Los modelos pequeños pueden ejecutarse cerca de la línea y cada respuesta cita sus fuentes.</a:t>
             </a:r>
           </a:p>
         </p:txBody>
@@ -3956,7 +3956,7 @@
           <a:lstStyle/>
           <a:p>
             <a:r>
-              <a:t>Optimización energética</a:t>
+              <a:t>Asistentes con IA generativa</a:t>
             </a:r>
           </a:p>
         </p:txBody>
@@ -3977,25 +3977,25 @@
           <a:lstStyle/>
           <a:p>
             <a:r>
-              <a:t>Modelos de consumo en tiempo real</a:t>
+              <a:t>Respuestas sobre manuales y procedimientos</a:t>
             </a:r>
           </a:p>
           <a:p>
             <a:pPr/>
             <a:r>
-              <a:t>Ajuste automático de consignas</a:t>
+              <a:t>Búsqueda RAG en documentación técnica</a:t>
             </a:r>
           </a:p>
           <a:p>
             <a:pPr/>
             <a:r>
-              <a:t>Ahorro 5-15% en energía</a:t>
+              <a:t>Modelos pequeños cerca de la línea</a:t>
             </a:r>
           </a:p>
           <a:p>
             <a:pPr/>
             <a:r>
-              <a:t>Reduce scope 2 directamente</a:t>
+              <a:t>Fuentes citadas en cada respuesta</a:t>
             </a:r>
           </a:p>
         </p:txBody>

</xml_diff>